<commit_message>
fix: 行动清单页背景色 — s14.background → s15.background
根因: 旧结束页重命名s14→s15时漏了.background行,
      导致s14(行动清单)背景被错误覆盖为C.navy
</commit_message>
<xml_diff>
--- a/Claude-Token优化最佳实践.pptx
+++ b/Claude-Token优化最佳实践.pptx
@@ -7436,7 +7436,7 @@
     <p:bg>
       <p:bgPr>
         <a:solidFill>
-          <a:srgbClr val="1E2761"/>
+          <a:srgbClr val="F5F7FA"/>
         </a:solidFill>
       </p:bgPr>
     </p:bg>
@@ -8282,6 +8282,13 @@
 <file path=ppt/slides/slide15.xml><?xml version="1.0" encoding="utf-8"?>
 <p:sld xmlns:a="http://schemas.openxmlformats.org/drawingml/2006/main" xmlns:r="http://schemas.openxmlformats.org/officeDocument/2006/relationships" xmlns:p="http://schemas.openxmlformats.org/presentationml/2006/main">
   <p:cSld name="Slide 15">
+    <p:bg>
+      <p:bgPr>
+        <a:solidFill>
+          <a:srgbClr val="1E2761"/>
+        </a:solidFill>
+      </p:bgPr>
+    </p:bg>
     <p:spTree>
       <p:nvGrpSpPr>
         <p:cNvPr id="1" name=""/>

</xml_diff>